<commit_message>
Entrega final - Cierre de curso
</commit_message>
<xml_diff>
--- a/PitchFinalNABC_AgenteCostosEditoriales.pptx
+++ b/PitchFinalNABC_AgenteCostosEditoriales.pptx
@@ -289,7 +289,200 @@
           <a:lstStyle/>
           <a:p>
             <a:r>
-              <a:t>Apertura (15 s): “Hoy, el analista de costos y gastos de la editorial consolida a mano los gastos de cada proyecto para poder fijar el precio de un libro. Ese proceso es lento y puede omitir gastos. Construimos un agente que lo hace en segundos, con evidencia y trazabilidad.”</a:t>
+              <a:rPr dirty="0"/>
+              <a:t>Apertura (15 s): “Hoy, el </a:t>
+            </a:r>
+            <a:r>
+              <a:rPr dirty="0" err="1"/>
+              <a:t>analista</a:t>
+            </a:r>
+            <a:r>
+              <a:rPr dirty="0"/>
+              <a:t> de </a:t>
+            </a:r>
+            <a:r>
+              <a:rPr dirty="0" err="1"/>
+              <a:t>costos</a:t>
+            </a:r>
+            <a:r>
+              <a:rPr dirty="0"/>
+              <a:t> y </a:t>
+            </a:r>
+            <a:r>
+              <a:rPr dirty="0" err="1"/>
+              <a:t>gastos</a:t>
+            </a:r>
+            <a:r>
+              <a:rPr dirty="0"/>
+              <a:t> de la editorial </a:t>
+            </a:r>
+            <a:r>
+              <a:rPr dirty="0" err="1"/>
+              <a:t>consolida</a:t>
+            </a:r>
+            <a:r>
+              <a:rPr dirty="0"/>
+              <a:t> a mano </a:t>
+            </a:r>
+            <a:r>
+              <a:rPr dirty="0" err="1"/>
+              <a:t>los</a:t>
+            </a:r>
+            <a:r>
+              <a:rPr dirty="0"/>
+              <a:t> </a:t>
+            </a:r>
+            <a:r>
+              <a:rPr dirty="0" err="1"/>
+              <a:t>gastos</a:t>
+            </a:r>
+            <a:r>
+              <a:rPr dirty="0"/>
+              <a:t> de </a:t>
+            </a:r>
+            <a:r>
+              <a:rPr dirty="0" err="1"/>
+              <a:t>cada</a:t>
+            </a:r>
+            <a:r>
+              <a:rPr dirty="0"/>
+              <a:t> </a:t>
+            </a:r>
+            <a:r>
+              <a:rPr dirty="0" err="1"/>
+              <a:t>proyecto</a:t>
+            </a:r>
+            <a:r>
+              <a:rPr dirty="0"/>
+              <a:t> para </a:t>
+            </a:r>
+            <a:r>
+              <a:rPr dirty="0" err="1"/>
+              <a:t>poder</a:t>
+            </a:r>
+            <a:r>
+              <a:rPr dirty="0"/>
+              <a:t> </a:t>
+            </a:r>
+            <a:r>
+              <a:rPr dirty="0" err="1"/>
+              <a:t>fijar</a:t>
+            </a:r>
+            <a:r>
+              <a:rPr dirty="0"/>
+              <a:t> el </a:t>
+            </a:r>
+            <a:r>
+              <a:rPr dirty="0" err="1"/>
+              <a:t>precio</a:t>
+            </a:r>
+            <a:r>
+              <a:rPr dirty="0"/>
+              <a:t> de un </a:t>
+            </a:r>
+            <a:r>
+              <a:rPr dirty="0" err="1"/>
+              <a:t>libro</a:t>
+            </a:r>
+            <a:r>
+              <a:rPr dirty="0"/>
+              <a:t>. Ese </a:t>
+            </a:r>
+            <a:r>
+              <a:rPr dirty="0" err="1"/>
+              <a:t>proceso</a:t>
+            </a:r>
+            <a:r>
+              <a:rPr dirty="0"/>
+              <a:t> es lento y </a:t>
+            </a:r>
+            <a:r>
+              <a:rPr dirty="0" err="1"/>
+              <a:t>puede</a:t>
+            </a:r>
+            <a:r>
+              <a:rPr dirty="0"/>
+              <a:t> </a:t>
+            </a:r>
+            <a:r>
+              <a:rPr dirty="0" err="1"/>
+              <a:t>omitir</a:t>
+            </a:r>
+            <a:r>
+              <a:rPr dirty="0"/>
+              <a:t> </a:t>
+            </a:r>
+            <a:r>
+              <a:rPr dirty="0" err="1"/>
+              <a:t>gastos</a:t>
+            </a:r>
+            <a:r>
+              <a:rPr dirty="0"/>
+              <a:t>. </a:t>
+            </a:r>
+            <a:r>
+              <a:rPr dirty="0" err="1"/>
+              <a:t>Construimos</a:t>
+            </a:r>
+            <a:r>
+              <a:rPr dirty="0"/>
+              <a:t> un </a:t>
+            </a:r>
+            <a:r>
+              <a:rPr dirty="0" err="1"/>
+              <a:t>agente</a:t>
+            </a:r>
+            <a:r>
+              <a:rPr dirty="0"/>
+              <a:t> </a:t>
+            </a:r>
+            <a:r>
+              <a:rPr dirty="0" err="1"/>
+              <a:t>que</a:t>
+            </a:r>
+            <a:r>
+              <a:rPr dirty="0"/>
+              <a:t> lo </a:t>
+            </a:r>
+            <a:r>
+              <a:rPr dirty="0" err="1"/>
+              <a:t>hace</a:t>
+            </a:r>
+            <a:r>
+              <a:rPr dirty="0"/>
+              <a:t> </a:t>
+            </a:r>
+            <a:r>
+              <a:rPr dirty="0" err="1"/>
+              <a:t>en</a:t>
+            </a:r>
+            <a:r>
+              <a:rPr dirty="0"/>
+              <a:t> </a:t>
+            </a:r>
+            <a:r>
+              <a:rPr dirty="0" err="1"/>
+              <a:t>segundos</a:t>
+            </a:r>
+            <a:r>
+              <a:rPr dirty="0"/>
+              <a:t>, con </a:t>
+            </a:r>
+            <a:r>
+              <a:rPr dirty="0" err="1"/>
+              <a:t>evidencia</a:t>
+            </a:r>
+            <a:r>
+              <a:rPr dirty="0"/>
+              <a:t> y </a:t>
+            </a:r>
+            <a:r>
+              <a:rPr dirty="0" err="1"/>
+              <a:t>trazabilidad</a:t>
+            </a:r>
+            <a:r>
+              <a:rPr dirty="0"/>
+              <a:t>.”</a:t>
             </a:r>
           </a:p>
         </p:txBody>
@@ -375,7 +568,232 @@
           <a:lstStyle/>
           <a:p>
             <a:r>
-              <a:t>Need (35 s): Describir el proceso actual: al cierre del registro de costos, contabilidad revisa los gastos y el analista los consolida en Excel. No se trata solo de lentitud: se trata de riesgo de omitir gastos y de no poder auditar cómo se llegó al precio. El problema existe aunque la IA no exista.</a:t>
+              <a:rPr dirty="0"/>
+              <a:t>Need (35 s): </a:t>
+            </a:r>
+            <a:r>
+              <a:rPr dirty="0" err="1"/>
+              <a:t>Describir</a:t>
+            </a:r>
+            <a:r>
+              <a:rPr dirty="0"/>
+              <a:t> el </a:t>
+            </a:r>
+            <a:r>
+              <a:rPr dirty="0" err="1"/>
+              <a:t>proceso</a:t>
+            </a:r>
+            <a:r>
+              <a:rPr dirty="0"/>
+              <a:t> actual: al </a:t>
+            </a:r>
+            <a:r>
+              <a:rPr dirty="0" err="1"/>
+              <a:t>cierre</a:t>
+            </a:r>
+            <a:r>
+              <a:rPr dirty="0"/>
+              <a:t> del </a:t>
+            </a:r>
+            <a:r>
+              <a:rPr dirty="0" err="1"/>
+              <a:t>registro</a:t>
+            </a:r>
+            <a:r>
+              <a:rPr dirty="0"/>
+              <a:t> de </a:t>
+            </a:r>
+            <a:r>
+              <a:rPr dirty="0" err="1"/>
+              <a:t>costos</a:t>
+            </a:r>
+            <a:r>
+              <a:rPr dirty="0"/>
+              <a:t>, </a:t>
+            </a:r>
+            <a:r>
+              <a:rPr dirty="0" err="1"/>
+              <a:t>contabilidad</a:t>
+            </a:r>
+            <a:r>
+              <a:rPr dirty="0"/>
+              <a:t> </a:t>
+            </a:r>
+            <a:r>
+              <a:rPr dirty="0" err="1"/>
+              <a:t>revisa</a:t>
+            </a:r>
+            <a:r>
+              <a:rPr dirty="0"/>
+              <a:t> </a:t>
+            </a:r>
+            <a:r>
+              <a:rPr dirty="0" err="1"/>
+              <a:t>los</a:t>
+            </a:r>
+            <a:r>
+              <a:rPr dirty="0"/>
+              <a:t> </a:t>
+            </a:r>
+            <a:r>
+              <a:rPr dirty="0" err="1"/>
+              <a:t>gastos</a:t>
+            </a:r>
+            <a:r>
+              <a:rPr dirty="0"/>
+              <a:t> y el </a:t>
+            </a:r>
+            <a:r>
+              <a:rPr dirty="0" err="1"/>
+              <a:t>analista</a:t>
+            </a:r>
+            <a:r>
+              <a:rPr dirty="0"/>
+              <a:t> </a:t>
+            </a:r>
+            <a:r>
+              <a:rPr dirty="0" err="1"/>
+              <a:t>los</a:t>
+            </a:r>
+            <a:r>
+              <a:rPr dirty="0"/>
+              <a:t> </a:t>
+            </a:r>
+            <a:r>
+              <a:rPr dirty="0" err="1"/>
+              <a:t>consolida</a:t>
+            </a:r>
+            <a:r>
+              <a:rPr dirty="0"/>
+              <a:t> </a:t>
+            </a:r>
+            <a:r>
+              <a:rPr dirty="0" err="1"/>
+              <a:t>en</a:t>
+            </a:r>
+            <a:r>
+              <a:rPr dirty="0"/>
+              <a:t> Excel. No se </a:t>
+            </a:r>
+            <a:r>
+              <a:rPr dirty="0" err="1"/>
+              <a:t>trata</a:t>
+            </a:r>
+            <a:r>
+              <a:rPr dirty="0"/>
+              <a:t> solo de </a:t>
+            </a:r>
+            <a:r>
+              <a:rPr dirty="0" err="1"/>
+              <a:t>lentitud</a:t>
+            </a:r>
+            <a:r>
+              <a:rPr dirty="0"/>
+              <a:t>: se </a:t>
+            </a:r>
+            <a:r>
+              <a:rPr dirty="0" err="1"/>
+              <a:t>trata</a:t>
+            </a:r>
+            <a:r>
+              <a:rPr dirty="0"/>
+              <a:t> de </a:t>
+            </a:r>
+            <a:r>
+              <a:rPr dirty="0" err="1"/>
+              <a:t>riesgo</a:t>
+            </a:r>
+            <a:r>
+              <a:rPr dirty="0"/>
+              <a:t> de </a:t>
+            </a:r>
+            <a:r>
+              <a:rPr dirty="0" err="1"/>
+              <a:t>omitir</a:t>
+            </a:r>
+            <a:r>
+              <a:rPr dirty="0"/>
+              <a:t> </a:t>
+            </a:r>
+            <a:r>
+              <a:rPr dirty="0" err="1"/>
+              <a:t>gastos</a:t>
+            </a:r>
+            <a:r>
+              <a:rPr dirty="0"/>
+              <a:t> y de no </a:t>
+            </a:r>
+            <a:r>
+              <a:rPr dirty="0" err="1"/>
+              <a:t>poder</a:t>
+            </a:r>
+            <a:r>
+              <a:rPr dirty="0"/>
+              <a:t> </a:t>
+            </a:r>
+            <a:r>
+              <a:rPr dirty="0" err="1"/>
+              <a:t>auditar</a:t>
+            </a:r>
+            <a:r>
+              <a:rPr dirty="0"/>
+              <a:t> </a:t>
+            </a:r>
+            <a:r>
+              <a:rPr dirty="0" err="1"/>
+              <a:t>cómo</a:t>
+            </a:r>
+            <a:r>
+              <a:rPr dirty="0"/>
+              <a:t> se </a:t>
+            </a:r>
+            <a:r>
+              <a:rPr dirty="0" err="1"/>
+              <a:t>llegó</a:t>
+            </a:r>
+            <a:r>
+              <a:rPr dirty="0"/>
+              <a:t> al </a:t>
+            </a:r>
+            <a:r>
+              <a:rPr dirty="0" err="1"/>
+              <a:t>precio</a:t>
+            </a:r>
+            <a:r>
+              <a:rPr dirty="0"/>
+              <a:t>. El </a:t>
+            </a:r>
+            <a:r>
+              <a:rPr dirty="0" err="1"/>
+              <a:t>problema</a:t>
+            </a:r>
+            <a:r>
+              <a:rPr dirty="0"/>
+              <a:t> </a:t>
+            </a:r>
+            <a:r>
+              <a:rPr dirty="0" err="1"/>
+              <a:t>existe</a:t>
+            </a:r>
+            <a:r>
+              <a:rPr dirty="0"/>
+              <a:t> </a:t>
+            </a:r>
+            <a:r>
+              <a:rPr dirty="0" err="1"/>
+              <a:t>aunque</a:t>
+            </a:r>
+            <a:r>
+              <a:rPr dirty="0"/>
+              <a:t> la IA no </a:t>
+            </a:r>
+            <a:r>
+              <a:rPr dirty="0" err="1"/>
+              <a:t>exista</a:t>
+            </a:r>
+            <a:r>
+              <a:rPr dirty="0"/>
+              <a:t>.</a:t>
             </a:r>
           </a:p>
         </p:txBody>
@@ -461,7 +879,288 @@
           <a:lstStyle/>
           <a:p>
             <a:r>
-              <a:t>Need – evidencia (30 s): Mostrar el alcance del PoC: 4 proyectos editoriales y 20 gastos de prueba que replican la estructura real (tipo de gasto, proveedor, moneda). Señalar el caso 3232-0004: tiene cantidades inconsistentes y el sistema lo detecta en lugar de ocultarlo. Criterio de éxito: consolidar y proponer costo/precio en menos de 10 minutos, con registro trazable.</a:t>
+              <a:rPr dirty="0"/>
+              <a:t>Need – </a:t>
+            </a:r>
+            <a:r>
+              <a:rPr dirty="0" err="1"/>
+              <a:t>evidencia</a:t>
+            </a:r>
+            <a:r>
+              <a:rPr dirty="0"/>
+              <a:t> (30 s): </a:t>
+            </a:r>
+            <a:r>
+              <a:rPr dirty="0" err="1"/>
+              <a:t>Mostrar</a:t>
+            </a:r>
+            <a:r>
+              <a:rPr dirty="0"/>
+              <a:t> el </a:t>
+            </a:r>
+            <a:r>
+              <a:rPr dirty="0" err="1"/>
+              <a:t>alcance</a:t>
+            </a:r>
+            <a:r>
+              <a:rPr dirty="0"/>
+              <a:t> del PoC: 4 </a:t>
+            </a:r>
+            <a:r>
+              <a:rPr dirty="0" err="1"/>
+              <a:t>proyectos</a:t>
+            </a:r>
+            <a:r>
+              <a:rPr dirty="0"/>
+              <a:t> </a:t>
+            </a:r>
+            <a:r>
+              <a:rPr dirty="0" err="1"/>
+              <a:t>editoriales</a:t>
+            </a:r>
+            <a:r>
+              <a:rPr dirty="0"/>
+              <a:t> y 20 </a:t>
+            </a:r>
+            <a:r>
+              <a:rPr dirty="0" err="1"/>
+              <a:t>gastos</a:t>
+            </a:r>
+            <a:r>
+              <a:rPr dirty="0"/>
+              <a:t> de </a:t>
+            </a:r>
+            <a:r>
+              <a:rPr dirty="0" err="1"/>
+              <a:t>prueba</a:t>
+            </a:r>
+            <a:r>
+              <a:rPr dirty="0"/>
+              <a:t> </a:t>
+            </a:r>
+            <a:r>
+              <a:rPr dirty="0" err="1"/>
+              <a:t>que</a:t>
+            </a:r>
+            <a:r>
+              <a:rPr dirty="0"/>
+              <a:t> </a:t>
+            </a:r>
+            <a:r>
+              <a:rPr dirty="0" err="1"/>
+              <a:t>replican</a:t>
+            </a:r>
+            <a:r>
+              <a:rPr dirty="0"/>
+              <a:t> la </a:t>
+            </a:r>
+            <a:r>
+              <a:rPr dirty="0" err="1"/>
+              <a:t>estructura</a:t>
+            </a:r>
+            <a:r>
+              <a:rPr dirty="0"/>
+              <a:t> real (</a:t>
+            </a:r>
+            <a:r>
+              <a:rPr dirty="0" err="1"/>
+              <a:t>tipo</a:t>
+            </a:r>
+            <a:r>
+              <a:rPr dirty="0"/>
+              <a:t> de </a:t>
+            </a:r>
+            <a:r>
+              <a:rPr dirty="0" err="1"/>
+              <a:t>gasto</a:t>
+            </a:r>
+            <a:r>
+              <a:rPr dirty="0"/>
+              <a:t>, </a:t>
+            </a:r>
+            <a:r>
+              <a:rPr dirty="0" err="1"/>
+              <a:t>proveedor</a:t>
+            </a:r>
+            <a:r>
+              <a:rPr dirty="0"/>
+              <a:t>, </a:t>
+            </a:r>
+            <a:r>
+              <a:rPr dirty="0" err="1"/>
+              <a:t>moneda</a:t>
+            </a:r>
+            <a:r>
+              <a:rPr dirty="0"/>
+              <a:t>). </a:t>
+            </a:r>
+            <a:r>
+              <a:rPr dirty="0" err="1"/>
+              <a:t>Señalar</a:t>
+            </a:r>
+            <a:r>
+              <a:rPr dirty="0"/>
+              <a:t> el </a:t>
+            </a:r>
+            <a:r>
+              <a:rPr dirty="0" err="1"/>
+              <a:t>caso</a:t>
+            </a:r>
+            <a:r>
+              <a:rPr dirty="0"/>
+              <a:t> 3232-0004: </a:t>
+            </a:r>
+            <a:r>
+              <a:rPr dirty="0" err="1"/>
+              <a:t>tiene</a:t>
+            </a:r>
+            <a:r>
+              <a:rPr dirty="0"/>
+              <a:t> </a:t>
+            </a:r>
+            <a:r>
+              <a:rPr dirty="0" err="1"/>
+              <a:t>cantidades</a:t>
+            </a:r>
+            <a:r>
+              <a:rPr dirty="0"/>
+              <a:t> </a:t>
+            </a:r>
+            <a:r>
+              <a:rPr dirty="0" err="1"/>
+              <a:t>inconsistentes</a:t>
+            </a:r>
+            <a:r>
+              <a:rPr dirty="0"/>
+              <a:t> y el </a:t>
+            </a:r>
+            <a:r>
+              <a:rPr dirty="0" err="1"/>
+              <a:t>sistema</a:t>
+            </a:r>
+            <a:r>
+              <a:rPr dirty="0"/>
+              <a:t> lo </a:t>
+            </a:r>
+            <a:r>
+              <a:rPr dirty="0" err="1"/>
+              <a:t>detecta</a:t>
+            </a:r>
+            <a:r>
+              <a:rPr dirty="0"/>
+              <a:t> </a:t>
+            </a:r>
+            <a:r>
+              <a:rPr dirty="0" err="1"/>
+              <a:t>en</a:t>
+            </a:r>
+            <a:r>
+              <a:rPr dirty="0"/>
+              <a:t> </a:t>
+            </a:r>
+            <a:r>
+              <a:rPr dirty="0" err="1"/>
+              <a:t>lugar</a:t>
+            </a:r>
+            <a:r>
+              <a:rPr dirty="0"/>
+              <a:t> de </a:t>
+            </a:r>
+            <a:r>
+              <a:rPr dirty="0" err="1"/>
+              <a:t>ocultarlo</a:t>
+            </a:r>
+            <a:r>
+              <a:rPr dirty="0"/>
+              <a:t>. </a:t>
+            </a:r>
+            <a:r>
+              <a:rPr dirty="0" err="1"/>
+              <a:t>Criterio</a:t>
+            </a:r>
+            <a:r>
+              <a:rPr dirty="0"/>
+              <a:t> de </a:t>
+            </a:r>
+            <a:r>
+              <a:rPr dirty="0" err="1"/>
+              <a:t>éxito</a:t>
+            </a:r>
+            <a:r>
+              <a:rPr dirty="0"/>
+              <a:t>: </a:t>
+            </a:r>
+            <a:r>
+              <a:rPr dirty="0" err="1"/>
+              <a:t>consolidar</a:t>
+            </a:r>
+            <a:r>
+              <a:rPr dirty="0"/>
+              <a:t> y </a:t>
+            </a:r>
+            <a:r>
+              <a:rPr dirty="0" err="1"/>
+              <a:t>proponer</a:t>
+            </a:r>
+            <a:r>
+              <a:rPr dirty="0"/>
+              <a:t> </a:t>
+            </a:r>
+            <a:r>
+              <a:rPr dirty="0" err="1"/>
+              <a:t>costo</a:t>
+            </a:r>
+            <a:r>
+              <a:rPr dirty="0"/>
+              <a:t>/</a:t>
+            </a:r>
+            <a:r>
+              <a:rPr dirty="0" err="1"/>
+              <a:t>precio</a:t>
+            </a:r>
+            <a:r>
+              <a:rPr dirty="0"/>
+              <a:t> </a:t>
+            </a:r>
+            <a:r>
+              <a:rPr dirty="0" err="1"/>
+              <a:t>en</a:t>
+            </a:r>
+            <a:r>
+              <a:rPr dirty="0"/>
+              <a:t> </a:t>
+            </a:r>
+            <a:r>
+              <a:rPr dirty="0" err="1"/>
+              <a:t>menos</a:t>
+            </a:r>
+            <a:r>
+              <a:rPr dirty="0"/>
+              <a:t> de 10 </a:t>
+            </a:r>
+            <a:r>
+              <a:rPr dirty="0" err="1"/>
+              <a:t>minutos</a:t>
+            </a:r>
+            <a:r>
+              <a:rPr dirty="0"/>
+              <a:t>, con </a:t>
+            </a:r>
+            <a:r>
+              <a:rPr dirty="0" err="1"/>
+              <a:t>registro</a:t>
+            </a:r>
+            <a:r>
+              <a:rPr dirty="0"/>
+              <a:t> </a:t>
+            </a:r>
+            <a:r>
+              <a:rPr dirty="0" err="1"/>
+              <a:t>trazable</a:t>
+            </a:r>
+            <a:r>
+              <a:rPr dirty="0"/>
+              <a:t>.</a:t>
             </a:r>
           </a:p>
         </p:txBody>
@@ -547,7 +1246,248 @@
           <a:lstStyle/>
           <a:p>
             <a:r>
-              <a:t>Approach (40 s): “El analista hace una pregunta en lenguaje natural. El agente (Gemini 2.5 Flash orquestado con LangChain) interpreta la intención y elige una de las 13 tools MCP; cada tool es una pregunta de negocio concreta sobre SQLite, no SQL libre. La respuesta llega con costo propuesto, precio sugerido con margen del 35%, score de confianza y campos dudosos. Si no hay evidencia, el agente lo dice; no inventa.”</a:t>
+              <a:rPr dirty="0"/>
+              <a:t>Approach (40 s): “El </a:t>
+            </a:r>
+            <a:r>
+              <a:rPr dirty="0" err="1"/>
+              <a:t>analista</a:t>
+            </a:r>
+            <a:r>
+              <a:rPr dirty="0"/>
+              <a:t> </a:t>
+            </a:r>
+            <a:r>
+              <a:rPr dirty="0" err="1"/>
+              <a:t>hace</a:t>
+            </a:r>
+            <a:r>
+              <a:rPr dirty="0"/>
+              <a:t> </a:t>
+            </a:r>
+            <a:r>
+              <a:rPr dirty="0" err="1"/>
+              <a:t>una</a:t>
+            </a:r>
+            <a:r>
+              <a:rPr dirty="0"/>
+              <a:t> </a:t>
+            </a:r>
+            <a:r>
+              <a:rPr dirty="0" err="1"/>
+              <a:t>pregunta</a:t>
+            </a:r>
+            <a:r>
+              <a:rPr dirty="0"/>
+              <a:t> </a:t>
+            </a:r>
+            <a:r>
+              <a:rPr dirty="0" err="1"/>
+              <a:t>en</a:t>
+            </a:r>
+            <a:r>
+              <a:rPr dirty="0"/>
+              <a:t> </a:t>
+            </a:r>
+            <a:r>
+              <a:rPr dirty="0" err="1"/>
+              <a:t>lenguaje</a:t>
+            </a:r>
+            <a:r>
+              <a:rPr dirty="0"/>
+              <a:t> natural. El </a:t>
+            </a:r>
+            <a:r>
+              <a:rPr dirty="0" err="1"/>
+              <a:t>agente</a:t>
+            </a:r>
+            <a:r>
+              <a:rPr dirty="0"/>
+              <a:t> (Gemini 2.5 Flash </a:t>
+            </a:r>
+            <a:r>
+              <a:rPr dirty="0" err="1"/>
+              <a:t>orquestado</a:t>
+            </a:r>
+            <a:r>
+              <a:rPr dirty="0"/>
+              <a:t> con </a:t>
+            </a:r>
+            <a:r>
+              <a:rPr dirty="0" err="1"/>
+              <a:t>LangChain</a:t>
+            </a:r>
+            <a:r>
+              <a:rPr dirty="0"/>
+              <a:t>) </a:t>
+            </a:r>
+            <a:r>
+              <a:rPr dirty="0" err="1"/>
+              <a:t>interpreta</a:t>
+            </a:r>
+            <a:r>
+              <a:rPr dirty="0"/>
+              <a:t> la </a:t>
+            </a:r>
+            <a:r>
+              <a:rPr dirty="0" err="1"/>
+              <a:t>intención</a:t>
+            </a:r>
+            <a:r>
+              <a:rPr dirty="0"/>
+              <a:t> y </a:t>
+            </a:r>
+            <a:r>
+              <a:rPr dirty="0" err="1"/>
+              <a:t>elige</a:t>
+            </a:r>
+            <a:r>
+              <a:rPr dirty="0"/>
+              <a:t> </a:t>
+            </a:r>
+            <a:r>
+              <a:rPr dirty="0" err="1"/>
+              <a:t>una</a:t>
+            </a:r>
+            <a:r>
+              <a:rPr dirty="0"/>
+              <a:t> de las 13 tools MCP; </a:t>
+            </a:r>
+            <a:r>
+              <a:rPr dirty="0" err="1"/>
+              <a:t>cada</a:t>
+            </a:r>
+            <a:r>
+              <a:rPr dirty="0"/>
+              <a:t> tool es </a:t>
+            </a:r>
+            <a:r>
+              <a:rPr dirty="0" err="1"/>
+              <a:t>una</a:t>
+            </a:r>
+            <a:r>
+              <a:rPr dirty="0"/>
+              <a:t> </a:t>
+            </a:r>
+            <a:r>
+              <a:rPr dirty="0" err="1"/>
+              <a:t>pregunta</a:t>
+            </a:r>
+            <a:r>
+              <a:rPr dirty="0"/>
+              <a:t> de </a:t>
+            </a:r>
+            <a:r>
+              <a:rPr dirty="0" err="1"/>
+              <a:t>negocio</a:t>
+            </a:r>
+            <a:r>
+              <a:rPr dirty="0"/>
+              <a:t> </a:t>
+            </a:r>
+            <a:r>
+              <a:rPr dirty="0" err="1"/>
+              <a:t>concreta</a:t>
+            </a:r>
+            <a:r>
+              <a:rPr dirty="0"/>
+              <a:t> </a:t>
+            </a:r>
+            <a:r>
+              <a:rPr dirty="0" err="1"/>
+              <a:t>sobre</a:t>
+            </a:r>
+            <a:r>
+              <a:rPr dirty="0"/>
+              <a:t> SQLite, no SQL libre. La </a:t>
+            </a:r>
+            <a:r>
+              <a:rPr dirty="0" err="1"/>
+              <a:t>respuesta</a:t>
+            </a:r>
+            <a:r>
+              <a:rPr dirty="0"/>
+              <a:t> </a:t>
+            </a:r>
+            <a:r>
+              <a:rPr dirty="0" err="1"/>
+              <a:t>llega</a:t>
+            </a:r>
+            <a:r>
+              <a:rPr dirty="0"/>
+              <a:t> con </a:t>
+            </a:r>
+            <a:r>
+              <a:rPr dirty="0" err="1"/>
+              <a:t>costo</a:t>
+            </a:r>
+            <a:r>
+              <a:rPr dirty="0"/>
+              <a:t> </a:t>
+            </a:r>
+            <a:r>
+              <a:rPr dirty="0" err="1"/>
+              <a:t>propuesto</a:t>
+            </a:r>
+            <a:r>
+              <a:rPr dirty="0"/>
+              <a:t>, </a:t>
+            </a:r>
+            <a:r>
+              <a:rPr dirty="0" err="1"/>
+              <a:t>precio</a:t>
+            </a:r>
+            <a:r>
+              <a:rPr dirty="0"/>
+              <a:t> </a:t>
+            </a:r>
+            <a:r>
+              <a:rPr dirty="0" err="1"/>
+              <a:t>sugerido</a:t>
+            </a:r>
+            <a:r>
+              <a:rPr dirty="0"/>
+              <a:t> con </a:t>
+            </a:r>
+            <a:r>
+              <a:rPr dirty="0" err="1"/>
+              <a:t>margen</a:t>
+            </a:r>
+            <a:r>
+              <a:rPr dirty="0"/>
+              <a:t> del 35%, score de confianza y campos </a:t>
+            </a:r>
+            <a:r>
+              <a:rPr dirty="0" err="1"/>
+              <a:t>dudosos</a:t>
+            </a:r>
+            <a:r>
+              <a:rPr dirty="0"/>
+              <a:t>. Si no hay </a:t>
+            </a:r>
+            <a:r>
+              <a:rPr dirty="0" err="1"/>
+              <a:t>evidencia</a:t>
+            </a:r>
+            <a:r>
+              <a:rPr dirty="0"/>
+              <a:t>, el </a:t>
+            </a:r>
+            <a:r>
+              <a:rPr dirty="0" err="1"/>
+              <a:t>agente</a:t>
+            </a:r>
+            <a:r>
+              <a:rPr dirty="0"/>
+              <a:t> lo dice; no </a:t>
+            </a:r>
+            <a:r>
+              <a:rPr dirty="0" err="1"/>
+              <a:t>inventa</a:t>
+            </a:r>
+            <a:r>
+              <a:rPr dirty="0"/>
+              <a:t>.”</a:t>
             </a:r>
           </a:p>
         </p:txBody>
@@ -633,7 +1573,192 @@
           <a:lstStyle/>
           <a:p>
             <a:r>
-              <a:t>Approach – arquitectura (45 s): Recorrer el flujo: CSV → SQLite (tabla gastos_proyecto + vista consolidada e índices) → servidor MCP local (FastMCP) que publica 13 tools de solo lectura → agente LangChain con system prompt y reglas → notebook/playground. Cada cálculo escribe en logs_inferencia (id, timestamp, propuesta, score, latencia) y las corridas quedan trazadas en LangSmith.</a:t>
+              <a:rPr dirty="0"/>
+              <a:t>Approach – </a:t>
+            </a:r>
+            <a:r>
+              <a:rPr dirty="0" err="1"/>
+              <a:t>arquitectura</a:t>
+            </a:r>
+            <a:r>
+              <a:rPr dirty="0"/>
+              <a:t> (45 s): </a:t>
+            </a:r>
+            <a:r>
+              <a:rPr dirty="0" err="1"/>
+              <a:t>Recorrer</a:t>
+            </a:r>
+            <a:r>
+              <a:rPr dirty="0"/>
+              <a:t> el </a:t>
+            </a:r>
+            <a:r>
+              <a:rPr dirty="0" err="1"/>
+              <a:t>flujo</a:t>
+            </a:r>
+            <a:r>
+              <a:rPr dirty="0"/>
+              <a:t>: CSV → SQLite (</a:t>
+            </a:r>
+            <a:r>
+              <a:rPr dirty="0" err="1"/>
+              <a:t>tabla</a:t>
+            </a:r>
+            <a:r>
+              <a:rPr dirty="0"/>
+              <a:t> </a:t>
+            </a:r>
+            <a:r>
+              <a:rPr dirty="0" err="1"/>
+              <a:t>gastos_proyecto</a:t>
+            </a:r>
+            <a:r>
+              <a:rPr dirty="0"/>
+              <a:t> + vista </a:t>
+            </a:r>
+            <a:r>
+              <a:rPr dirty="0" err="1"/>
+              <a:t>consolidada</a:t>
+            </a:r>
+            <a:r>
+              <a:rPr dirty="0"/>
+              <a:t> e </a:t>
+            </a:r>
+            <a:r>
+              <a:rPr dirty="0" err="1"/>
+              <a:t>índices</a:t>
+            </a:r>
+            <a:r>
+              <a:rPr dirty="0"/>
+              <a:t>) → </a:t>
+            </a:r>
+            <a:r>
+              <a:rPr dirty="0" err="1"/>
+              <a:t>servidor</a:t>
+            </a:r>
+            <a:r>
+              <a:rPr dirty="0"/>
+              <a:t> MCP local (</a:t>
+            </a:r>
+            <a:r>
+              <a:rPr dirty="0" err="1"/>
+              <a:t>FastMCP</a:t>
+            </a:r>
+            <a:r>
+              <a:rPr dirty="0"/>
+              <a:t>) </a:t>
+            </a:r>
+            <a:r>
+              <a:rPr dirty="0" err="1"/>
+              <a:t>que</a:t>
+            </a:r>
+            <a:r>
+              <a:rPr dirty="0"/>
+              <a:t> publica 13 tools de solo </a:t>
+            </a:r>
+            <a:r>
+              <a:rPr dirty="0" err="1"/>
+              <a:t>lectura</a:t>
+            </a:r>
+            <a:r>
+              <a:rPr dirty="0"/>
+              <a:t> → </a:t>
+            </a:r>
+            <a:r>
+              <a:rPr dirty="0" err="1"/>
+              <a:t>agente</a:t>
+            </a:r>
+            <a:r>
+              <a:rPr dirty="0"/>
+              <a:t> </a:t>
+            </a:r>
+            <a:r>
+              <a:rPr dirty="0" err="1"/>
+              <a:t>LangChain</a:t>
+            </a:r>
+            <a:r>
+              <a:rPr dirty="0"/>
+              <a:t> con system prompt y </a:t>
+            </a:r>
+            <a:r>
+              <a:rPr dirty="0" err="1"/>
+              <a:t>reglas</a:t>
+            </a:r>
+            <a:r>
+              <a:rPr dirty="0"/>
+              <a:t> → notebook/playground. Cada </a:t>
+            </a:r>
+            <a:r>
+              <a:rPr dirty="0" err="1"/>
+              <a:t>cálculo</a:t>
+            </a:r>
+            <a:r>
+              <a:rPr dirty="0"/>
+              <a:t> escribe </a:t>
+            </a:r>
+            <a:r>
+              <a:rPr dirty="0" err="1"/>
+              <a:t>en</a:t>
+            </a:r>
+            <a:r>
+              <a:rPr dirty="0"/>
+              <a:t> </a:t>
+            </a:r>
+            <a:r>
+              <a:rPr dirty="0" err="1"/>
+              <a:t>logs_inferencia</a:t>
+            </a:r>
+            <a:r>
+              <a:rPr dirty="0"/>
+              <a:t> (id, timestamp, </a:t>
+            </a:r>
+            <a:r>
+              <a:rPr dirty="0" err="1"/>
+              <a:t>propuesta</a:t>
+            </a:r>
+            <a:r>
+              <a:rPr dirty="0"/>
+              <a:t>, score, </a:t>
+            </a:r>
+            <a:r>
+              <a:rPr dirty="0" err="1"/>
+              <a:t>latencia</a:t>
+            </a:r>
+            <a:r>
+              <a:rPr dirty="0"/>
+              <a:t>) y las corridas </a:t>
+            </a:r>
+            <a:r>
+              <a:rPr dirty="0" err="1"/>
+              <a:t>quedan</a:t>
+            </a:r>
+            <a:r>
+              <a:rPr dirty="0"/>
+              <a:t> </a:t>
+            </a:r>
+            <a:r>
+              <a:rPr dirty="0" err="1"/>
+              <a:t>trazadas</a:t>
+            </a:r>
+            <a:r>
+              <a:rPr dirty="0"/>
+              <a:t> </a:t>
+            </a:r>
+            <a:r>
+              <a:rPr dirty="0" err="1"/>
+              <a:t>en</a:t>
+            </a:r>
+            <a:r>
+              <a:rPr dirty="0"/>
+              <a:t> </a:t>
+            </a:r>
+            <a:r>
+              <a:rPr dirty="0" err="1"/>
+              <a:t>LangSmith</a:t>
+            </a:r>
+            <a:r>
+              <a:rPr dirty="0"/>
+              <a:t>.</a:t>
             </a:r>
           </a:p>
         </p:txBody>
@@ -719,7 +1844,264 @@
           <a:lstStyle/>
           <a:p>
             <a:r>
-              <a:t>Benefits per Costs (45 s): Beneficio observado: la propuesta de costo y precio se obtiene en segundos y queda registrada. Costo reconocido: consumo de API, mantener la fuente de datos vigente y validación humana del precio final. Hipótesis a validar en la siguiente etapa: medir línea base del proceso manual vs. tiempo con el agente, y tasa de aceptación del precio sugerido.</a:t>
+              <a:rPr dirty="0"/>
+              <a:t>Benefits per Costs (45 s): </a:t>
+            </a:r>
+            <a:r>
+              <a:rPr dirty="0" err="1"/>
+              <a:t>Beneficio</a:t>
+            </a:r>
+            <a:r>
+              <a:rPr dirty="0"/>
+              <a:t> </a:t>
+            </a:r>
+            <a:r>
+              <a:rPr dirty="0" err="1"/>
+              <a:t>observado</a:t>
+            </a:r>
+            <a:r>
+              <a:rPr dirty="0"/>
+              <a:t>: la </a:t>
+            </a:r>
+            <a:r>
+              <a:rPr dirty="0" err="1"/>
+              <a:t>propuesta</a:t>
+            </a:r>
+            <a:r>
+              <a:rPr dirty="0"/>
+              <a:t> de </a:t>
+            </a:r>
+            <a:r>
+              <a:rPr dirty="0" err="1"/>
+              <a:t>costo</a:t>
+            </a:r>
+            <a:r>
+              <a:rPr dirty="0"/>
+              <a:t> y </a:t>
+            </a:r>
+            <a:r>
+              <a:rPr dirty="0" err="1"/>
+              <a:t>precio</a:t>
+            </a:r>
+            <a:r>
+              <a:rPr dirty="0"/>
+              <a:t> se </a:t>
+            </a:r>
+            <a:r>
+              <a:rPr dirty="0" err="1"/>
+              <a:t>obtiene</a:t>
+            </a:r>
+            <a:r>
+              <a:rPr dirty="0"/>
+              <a:t> </a:t>
+            </a:r>
+            <a:r>
+              <a:rPr dirty="0" err="1"/>
+              <a:t>en</a:t>
+            </a:r>
+            <a:r>
+              <a:rPr dirty="0"/>
+              <a:t> </a:t>
+            </a:r>
+            <a:r>
+              <a:rPr dirty="0" err="1"/>
+              <a:t>segundos</a:t>
+            </a:r>
+            <a:r>
+              <a:rPr dirty="0"/>
+              <a:t> y </a:t>
+            </a:r>
+            <a:r>
+              <a:rPr dirty="0" err="1"/>
+              <a:t>queda</a:t>
+            </a:r>
+            <a:r>
+              <a:rPr dirty="0"/>
+              <a:t> </a:t>
+            </a:r>
+            <a:r>
+              <a:rPr dirty="0" err="1"/>
+              <a:t>registrada</a:t>
+            </a:r>
+            <a:r>
+              <a:rPr dirty="0"/>
+              <a:t>. Costo </a:t>
+            </a:r>
+            <a:r>
+              <a:rPr dirty="0" err="1"/>
+              <a:t>reconocido</a:t>
+            </a:r>
+            <a:r>
+              <a:rPr dirty="0"/>
+              <a:t>: </a:t>
+            </a:r>
+            <a:r>
+              <a:rPr dirty="0" err="1"/>
+              <a:t>consumo</a:t>
+            </a:r>
+            <a:r>
+              <a:rPr dirty="0"/>
+              <a:t> de API, </a:t>
+            </a:r>
+            <a:r>
+              <a:rPr dirty="0" err="1"/>
+              <a:t>mantener</a:t>
+            </a:r>
+            <a:r>
+              <a:rPr dirty="0"/>
+              <a:t> la </a:t>
+            </a:r>
+            <a:r>
+              <a:rPr dirty="0" err="1"/>
+              <a:t>fuente</a:t>
+            </a:r>
+            <a:r>
+              <a:rPr dirty="0"/>
+              <a:t> de </a:t>
+            </a:r>
+            <a:r>
+              <a:rPr dirty="0" err="1"/>
+              <a:t>datos</a:t>
+            </a:r>
+            <a:r>
+              <a:rPr dirty="0"/>
+              <a:t> </a:t>
+            </a:r>
+            <a:r>
+              <a:rPr dirty="0" err="1"/>
+              <a:t>vigente</a:t>
+            </a:r>
+            <a:r>
+              <a:rPr dirty="0"/>
+              <a:t> y </a:t>
+            </a:r>
+            <a:r>
+              <a:rPr dirty="0" err="1"/>
+              <a:t>validación</a:t>
+            </a:r>
+            <a:r>
+              <a:rPr dirty="0"/>
+              <a:t> humana del </a:t>
+            </a:r>
+            <a:r>
+              <a:rPr dirty="0" err="1"/>
+              <a:t>precio</a:t>
+            </a:r>
+            <a:r>
+              <a:rPr dirty="0"/>
+              <a:t> final. </a:t>
+            </a:r>
+            <a:r>
+              <a:rPr dirty="0" err="1"/>
+              <a:t>Hipótesis</a:t>
+            </a:r>
+            <a:r>
+              <a:rPr dirty="0"/>
+              <a:t> a </a:t>
+            </a:r>
+            <a:r>
+              <a:rPr dirty="0" err="1"/>
+              <a:t>validar</a:t>
+            </a:r>
+            <a:r>
+              <a:rPr dirty="0"/>
+              <a:t> </a:t>
+            </a:r>
+            <a:r>
+              <a:rPr dirty="0" err="1"/>
+              <a:t>en</a:t>
+            </a:r>
+            <a:r>
+              <a:rPr dirty="0"/>
+              <a:t> la </a:t>
+            </a:r>
+            <a:r>
+              <a:rPr dirty="0" err="1"/>
+              <a:t>siguiente</a:t>
+            </a:r>
+            <a:r>
+              <a:rPr dirty="0"/>
+              <a:t> </a:t>
+            </a:r>
+            <a:r>
+              <a:rPr dirty="0" err="1"/>
+              <a:t>etapa</a:t>
+            </a:r>
+            <a:r>
+              <a:rPr dirty="0"/>
+              <a:t>: </a:t>
+            </a:r>
+            <a:r>
+              <a:rPr dirty="0" err="1"/>
+              <a:t>medir</a:t>
+            </a:r>
+            <a:r>
+              <a:rPr dirty="0"/>
+              <a:t> </a:t>
+            </a:r>
+            <a:r>
+              <a:rPr dirty="0" err="1"/>
+              <a:t>línea</a:t>
+            </a:r>
+            <a:r>
+              <a:rPr dirty="0"/>
+              <a:t> base del </a:t>
+            </a:r>
+            <a:r>
+              <a:rPr dirty="0" err="1"/>
+              <a:t>proceso</a:t>
+            </a:r>
+            <a:r>
+              <a:rPr dirty="0"/>
+              <a:t> manual vs. </a:t>
+            </a:r>
+            <a:r>
+              <a:rPr dirty="0" err="1"/>
+              <a:t>tiempo</a:t>
+            </a:r>
+            <a:r>
+              <a:rPr dirty="0"/>
+              <a:t> con el </a:t>
+            </a:r>
+            <a:r>
+              <a:rPr dirty="0" err="1"/>
+              <a:t>agente</a:t>
+            </a:r>
+            <a:r>
+              <a:rPr dirty="0"/>
+              <a:t>, y </a:t>
+            </a:r>
+            <a:r>
+              <a:rPr dirty="0" err="1"/>
+              <a:t>tasa</a:t>
+            </a:r>
+            <a:r>
+              <a:rPr dirty="0"/>
+              <a:t> de </a:t>
+            </a:r>
+            <a:r>
+              <a:rPr dirty="0" err="1"/>
+              <a:t>aceptación</a:t>
+            </a:r>
+            <a:r>
+              <a:rPr dirty="0"/>
+              <a:t> del </a:t>
+            </a:r>
+            <a:r>
+              <a:rPr dirty="0" err="1"/>
+              <a:t>precio</a:t>
+            </a:r>
+            <a:r>
+              <a:rPr dirty="0"/>
+              <a:t> </a:t>
+            </a:r>
+            <a:r>
+              <a:rPr dirty="0" err="1"/>
+              <a:t>sugerido</a:t>
+            </a:r>
+            <a:r>
+              <a:rPr dirty="0"/>
+              <a:t>.</a:t>
             </a:r>
           </a:p>
         </p:txBody>
@@ -805,7 +2187,224 @@
           <a:lstStyle/>
           <a:p>
             <a:r>
-              <a:t>Competence (35 s): Frente a la alternativa (Excel + revisión manual), el agente responde al momento y deja evidencia. Reconocemos límites: dataset ficticio, margen fijo del 35% y decisión final humana. No afirmamos tener un producto en producción: demostramos una capacidad funcional, acotada y trazable, con un plan claro para validar con datos reales.</a:t>
+              <a:rPr dirty="0"/>
+              <a:t>Competence (35 s): </a:t>
+            </a:r>
+            <a:r>
+              <a:rPr dirty="0" err="1"/>
+              <a:t>Frente</a:t>
+            </a:r>
+            <a:r>
+              <a:rPr dirty="0"/>
+              <a:t> a la </a:t>
+            </a:r>
+            <a:r>
+              <a:rPr dirty="0" err="1"/>
+              <a:t>alternativa</a:t>
+            </a:r>
+            <a:r>
+              <a:rPr dirty="0"/>
+              <a:t> (Excel + </a:t>
+            </a:r>
+            <a:r>
+              <a:rPr dirty="0" err="1"/>
+              <a:t>revisión</a:t>
+            </a:r>
+            <a:r>
+              <a:rPr dirty="0"/>
+              <a:t> manual), el </a:t>
+            </a:r>
+            <a:r>
+              <a:rPr dirty="0" err="1"/>
+              <a:t>agente</a:t>
+            </a:r>
+            <a:r>
+              <a:rPr dirty="0"/>
+              <a:t> </a:t>
+            </a:r>
+            <a:r>
+              <a:rPr dirty="0" err="1"/>
+              <a:t>responde</a:t>
+            </a:r>
+            <a:r>
+              <a:rPr dirty="0"/>
+              <a:t> al </a:t>
+            </a:r>
+            <a:r>
+              <a:rPr dirty="0" err="1"/>
+              <a:t>momento</a:t>
+            </a:r>
+            <a:r>
+              <a:rPr dirty="0"/>
+              <a:t> y </a:t>
+            </a:r>
+            <a:r>
+              <a:rPr dirty="0" err="1"/>
+              <a:t>deja</a:t>
+            </a:r>
+            <a:r>
+              <a:rPr dirty="0"/>
+              <a:t> </a:t>
+            </a:r>
+            <a:r>
+              <a:rPr dirty="0" err="1"/>
+              <a:t>evidencia</a:t>
+            </a:r>
+            <a:r>
+              <a:rPr dirty="0"/>
+              <a:t>. </a:t>
+            </a:r>
+            <a:r>
+              <a:rPr dirty="0" err="1"/>
+              <a:t>Reconocemos</a:t>
+            </a:r>
+            <a:r>
+              <a:rPr dirty="0"/>
+              <a:t> </a:t>
+            </a:r>
+            <a:r>
+              <a:rPr dirty="0" err="1"/>
+              <a:t>límites</a:t>
+            </a:r>
+            <a:r>
+              <a:rPr dirty="0"/>
+              <a:t>: dataset </a:t>
+            </a:r>
+            <a:r>
+              <a:rPr dirty="0" err="1"/>
+              <a:t>ficticio</a:t>
+            </a:r>
+            <a:r>
+              <a:rPr dirty="0"/>
+              <a:t>, </a:t>
+            </a:r>
+            <a:r>
+              <a:rPr dirty="0" err="1"/>
+              <a:t>margen</a:t>
+            </a:r>
+            <a:r>
+              <a:rPr dirty="0"/>
+              <a:t> </a:t>
+            </a:r>
+            <a:r>
+              <a:rPr dirty="0" err="1"/>
+              <a:t>fijo</a:t>
+            </a:r>
+            <a:r>
+              <a:rPr dirty="0"/>
+              <a:t> del 35% y </a:t>
+            </a:r>
+            <a:r>
+              <a:rPr dirty="0" err="1"/>
+              <a:t>decisión</a:t>
+            </a:r>
+            <a:r>
+              <a:rPr dirty="0"/>
+              <a:t> final humana. No </a:t>
+            </a:r>
+            <a:r>
+              <a:rPr dirty="0" err="1"/>
+              <a:t>afirmamos</a:t>
+            </a:r>
+            <a:r>
+              <a:rPr dirty="0"/>
+              <a:t> </a:t>
+            </a:r>
+            <a:r>
+              <a:rPr dirty="0" err="1"/>
+              <a:t>tener</a:t>
+            </a:r>
+            <a:r>
+              <a:rPr dirty="0"/>
+              <a:t> un </a:t>
+            </a:r>
+            <a:r>
+              <a:rPr dirty="0" err="1"/>
+              <a:t>producto</a:t>
+            </a:r>
+            <a:r>
+              <a:rPr dirty="0"/>
+              <a:t> </a:t>
+            </a:r>
+            <a:r>
+              <a:rPr dirty="0" err="1"/>
+              <a:t>en</a:t>
+            </a:r>
+            <a:r>
+              <a:rPr dirty="0"/>
+              <a:t> </a:t>
+            </a:r>
+            <a:r>
+              <a:rPr dirty="0" err="1"/>
+              <a:t>producción</a:t>
+            </a:r>
+            <a:r>
+              <a:rPr dirty="0"/>
+              <a:t>: </a:t>
+            </a:r>
+            <a:r>
+              <a:rPr dirty="0" err="1"/>
+              <a:t>demostramos</a:t>
+            </a:r>
+            <a:r>
+              <a:rPr dirty="0"/>
+              <a:t> </a:t>
+            </a:r>
+            <a:r>
+              <a:rPr dirty="0" err="1"/>
+              <a:t>una</a:t>
+            </a:r>
+            <a:r>
+              <a:rPr dirty="0"/>
+              <a:t> </a:t>
+            </a:r>
+            <a:r>
+              <a:rPr dirty="0" err="1"/>
+              <a:t>capacidad</a:t>
+            </a:r>
+            <a:r>
+              <a:rPr dirty="0"/>
+              <a:t> </a:t>
+            </a:r>
+            <a:r>
+              <a:rPr dirty="0" err="1"/>
+              <a:t>funcional</a:t>
+            </a:r>
+            <a:r>
+              <a:rPr dirty="0"/>
+              <a:t>, </a:t>
+            </a:r>
+            <a:r>
+              <a:rPr dirty="0" err="1"/>
+              <a:t>acotada</a:t>
+            </a:r>
+            <a:r>
+              <a:rPr dirty="0"/>
+              <a:t> y </a:t>
+            </a:r>
+            <a:r>
+              <a:rPr dirty="0" err="1"/>
+              <a:t>trazable</a:t>
+            </a:r>
+            <a:r>
+              <a:rPr dirty="0"/>
+              <a:t>, con un plan claro para </a:t>
+            </a:r>
+            <a:r>
+              <a:rPr dirty="0" err="1"/>
+              <a:t>validar</a:t>
+            </a:r>
+            <a:r>
+              <a:rPr dirty="0"/>
+              <a:t> con </a:t>
+            </a:r>
+            <a:r>
+              <a:rPr dirty="0" err="1"/>
+              <a:t>datos</a:t>
+            </a:r>
+            <a:r>
+              <a:rPr dirty="0"/>
+              <a:t> reales.</a:t>
             </a:r>
           </a:p>
         </p:txBody>
@@ -891,7 +2490,288 @@
           <a:lstStyle/>
           <a:p>
             <a:r>
-              <a:t>Demo (1:30–2:00): Caso feliz: “Calcula el costo y precio del proyecto 3232-0001” → el agente usa calcular_propuesta_costo_precio y devuelve propuesta con score alta. Caso límite: proyecto 3232-0004 → detecta cantidades inconsistentes y baja la confianza. Fuera de alcance: preguntar por un proyecto inexistente → responde que no lo encontró, sin inventar. Cierre: el flujo demuestra valor, trazabilidad y límites; siguiente paso, validar con datos reales y una interfaz Streamlit.</a:t>
+              <a:rPr dirty="0"/>
+              <a:t>Demo (1:30–2:00): Caso </a:t>
+            </a:r>
+            <a:r>
+              <a:rPr dirty="0" err="1"/>
+              <a:t>feliz</a:t>
+            </a:r>
+            <a:r>
+              <a:rPr dirty="0"/>
+              <a:t>: “</a:t>
+            </a:r>
+            <a:r>
+              <a:rPr dirty="0" err="1"/>
+              <a:t>Calcula</a:t>
+            </a:r>
+            <a:r>
+              <a:rPr dirty="0"/>
+              <a:t> el </a:t>
+            </a:r>
+            <a:r>
+              <a:rPr dirty="0" err="1"/>
+              <a:t>costo</a:t>
+            </a:r>
+            <a:r>
+              <a:rPr dirty="0"/>
+              <a:t> y </a:t>
+            </a:r>
+            <a:r>
+              <a:rPr dirty="0" err="1"/>
+              <a:t>precio</a:t>
+            </a:r>
+            <a:r>
+              <a:rPr dirty="0"/>
+              <a:t> del </a:t>
+            </a:r>
+            <a:r>
+              <a:rPr dirty="0" err="1"/>
+              <a:t>proyecto</a:t>
+            </a:r>
+            <a:r>
+              <a:rPr dirty="0"/>
+              <a:t> 3232-0001” → el </a:t>
+            </a:r>
+            <a:r>
+              <a:rPr dirty="0" err="1"/>
+              <a:t>agente</a:t>
+            </a:r>
+            <a:r>
+              <a:rPr dirty="0"/>
+              <a:t> </a:t>
+            </a:r>
+            <a:r>
+              <a:rPr dirty="0" err="1"/>
+              <a:t>usa</a:t>
+            </a:r>
+            <a:r>
+              <a:rPr dirty="0"/>
+              <a:t> </a:t>
+            </a:r>
+            <a:r>
+              <a:rPr dirty="0" err="1"/>
+              <a:t>calcular_propuesta_costo_precio</a:t>
+            </a:r>
+            <a:r>
+              <a:rPr dirty="0"/>
+              <a:t> y </a:t>
+            </a:r>
+            <a:r>
+              <a:rPr dirty="0" err="1"/>
+              <a:t>devuelve</a:t>
+            </a:r>
+            <a:r>
+              <a:rPr dirty="0"/>
+              <a:t> </a:t>
+            </a:r>
+            <a:r>
+              <a:rPr dirty="0" err="1"/>
+              <a:t>propuesta</a:t>
+            </a:r>
+            <a:r>
+              <a:rPr dirty="0"/>
+              <a:t> con score </a:t>
+            </a:r>
+            <a:r>
+              <a:rPr dirty="0" err="1"/>
+              <a:t>alta.</a:t>
+            </a:r>
+            <a:r>
+              <a:rPr dirty="0"/>
+              <a:t> Caso </a:t>
+            </a:r>
+            <a:r>
+              <a:rPr dirty="0" err="1"/>
+              <a:t>límite</a:t>
+            </a:r>
+            <a:r>
+              <a:rPr dirty="0"/>
+              <a:t>: </a:t>
+            </a:r>
+            <a:r>
+              <a:rPr dirty="0" err="1"/>
+              <a:t>proyecto</a:t>
+            </a:r>
+            <a:r>
+              <a:rPr dirty="0"/>
+              <a:t> 3232-0004 → </a:t>
+            </a:r>
+            <a:r>
+              <a:rPr dirty="0" err="1"/>
+              <a:t>detecta</a:t>
+            </a:r>
+            <a:r>
+              <a:rPr dirty="0"/>
+              <a:t> </a:t>
+            </a:r>
+            <a:r>
+              <a:rPr dirty="0" err="1"/>
+              <a:t>cantidades</a:t>
+            </a:r>
+            <a:r>
+              <a:rPr dirty="0"/>
+              <a:t> </a:t>
+            </a:r>
+            <a:r>
+              <a:rPr dirty="0" err="1"/>
+              <a:t>inconsistentes</a:t>
+            </a:r>
+            <a:r>
+              <a:rPr dirty="0"/>
+              <a:t> y baja la confianza. Fuera de </a:t>
+            </a:r>
+            <a:r>
+              <a:rPr dirty="0" err="1"/>
+              <a:t>alcance</a:t>
+            </a:r>
+            <a:r>
+              <a:rPr dirty="0"/>
+              <a:t>: </a:t>
+            </a:r>
+            <a:r>
+              <a:rPr dirty="0" err="1"/>
+              <a:t>preguntar</a:t>
+            </a:r>
+            <a:r>
+              <a:rPr dirty="0"/>
+              <a:t> </a:t>
+            </a:r>
+            <a:r>
+              <a:rPr dirty="0" err="1"/>
+              <a:t>por</a:t>
+            </a:r>
+            <a:r>
+              <a:rPr dirty="0"/>
+              <a:t> un </a:t>
+            </a:r>
+            <a:r>
+              <a:rPr dirty="0" err="1"/>
+              <a:t>proyecto</a:t>
+            </a:r>
+            <a:r>
+              <a:rPr dirty="0"/>
+              <a:t> </a:t>
+            </a:r>
+            <a:r>
+              <a:rPr dirty="0" err="1"/>
+              <a:t>inexistente</a:t>
+            </a:r>
+            <a:r>
+              <a:rPr dirty="0"/>
+              <a:t> → </a:t>
+            </a:r>
+            <a:r>
+              <a:rPr dirty="0" err="1"/>
+              <a:t>responde</a:t>
+            </a:r>
+            <a:r>
+              <a:rPr dirty="0"/>
+              <a:t> </a:t>
+            </a:r>
+            <a:r>
+              <a:rPr dirty="0" err="1"/>
+              <a:t>que</a:t>
+            </a:r>
+            <a:r>
+              <a:rPr dirty="0"/>
+              <a:t> no lo </a:t>
+            </a:r>
+            <a:r>
+              <a:rPr dirty="0" err="1"/>
+              <a:t>encontró</a:t>
+            </a:r>
+            <a:r>
+              <a:rPr dirty="0"/>
+              <a:t>, sin </a:t>
+            </a:r>
+            <a:r>
+              <a:rPr dirty="0" err="1"/>
+              <a:t>inventar</a:t>
+            </a:r>
+            <a:r>
+              <a:rPr dirty="0"/>
+              <a:t>. Cierre: el </a:t>
+            </a:r>
+            <a:r>
+              <a:rPr dirty="0" err="1"/>
+              <a:t>flujo</a:t>
+            </a:r>
+            <a:r>
+              <a:rPr dirty="0"/>
+              <a:t> </a:t>
+            </a:r>
+            <a:r>
+              <a:rPr dirty="0" err="1"/>
+              <a:t>demuestra</a:t>
+            </a:r>
+            <a:r>
+              <a:rPr dirty="0"/>
+              <a:t> valor, </a:t>
+            </a:r>
+            <a:r>
+              <a:rPr dirty="0" err="1"/>
+              <a:t>trazabilidad</a:t>
+            </a:r>
+            <a:r>
+              <a:rPr dirty="0"/>
+              <a:t> y </a:t>
+            </a:r>
+            <a:r>
+              <a:rPr dirty="0" err="1"/>
+              <a:t>límites</a:t>
+            </a:r>
+            <a:r>
+              <a:rPr dirty="0"/>
+              <a:t>; </a:t>
+            </a:r>
+            <a:r>
+              <a:rPr dirty="0" err="1"/>
+              <a:t>siguiente</a:t>
+            </a:r>
+            <a:r>
+              <a:rPr dirty="0"/>
+              <a:t> paso, </a:t>
+            </a:r>
+            <a:r>
+              <a:rPr dirty="0" err="1"/>
+              <a:t>validar</a:t>
+            </a:r>
+            <a:r>
+              <a:rPr dirty="0"/>
+              <a:t> con </a:t>
+            </a:r>
+            <a:r>
+              <a:rPr dirty="0" err="1"/>
+              <a:t>datos</a:t>
+            </a:r>
+            <a:r>
+              <a:rPr dirty="0"/>
+              <a:t> reales y </a:t>
+            </a:r>
+            <a:r>
+              <a:rPr dirty="0" err="1"/>
+              <a:t>una</a:t>
+            </a:r>
+            <a:r>
+              <a:rPr dirty="0"/>
+              <a:t> </a:t>
+            </a:r>
+            <a:r>
+              <a:rPr dirty="0" err="1"/>
+              <a:t>interfaz</a:t>
+            </a:r>
+            <a:r>
+              <a:rPr dirty="0"/>
+              <a:t> </a:t>
+            </a:r>
+            <a:r>
+              <a:rPr dirty="0" err="1"/>
+              <a:t>Streamlit</a:t>
+            </a:r>
+            <a:r>
+              <a:rPr dirty="0"/>
+              <a:t>.</a:t>
             </a:r>
           </a:p>
         </p:txBody>
@@ -1382,7 +3262,7 @@
                   <a:srgbClr val="007D7A"/>
                 </a:solidFill>
               </a:rPr>
-              <a:t>Template NABC + Demo funcional</a:t>
+              <a:t>Pitch NABC + Demo funcional</a:t>
             </a:r>
             <a:endParaRPr lang="en-US" sz="1800" dirty="0"/>
           </a:p>
@@ -1518,7 +3398,7 @@
                   <a:srgbClr val="007D7A"/>
                 </a:solidFill>
               </a:rPr>
-              <a:t>Objetivo: convencer con problema, solución, evidencia y demostración operativa.</a:t>
+              <a:t>Del cierre de costos al precio sugerido en segundos: consolidación automática, evidencia y trazabilidad.</a:t>
             </a:r>
             <a:endParaRPr lang="en-US" sz="1300" dirty="0"/>
           </a:p>
@@ -1712,7 +3592,7 @@
                   <a:srgbClr val="5F6B76"/>
                 </a:solidFill>
               </a:rPr>
-              <a:t>Definan el problema antes de hablar del modelo, la app o la arquitectura.</a:t>
+              <a:t>Fijar el precio de un material editorial depende hoy de consolidar a mano los gastos de producción.</a:t>
             </a:r>
             <a:endParaRPr lang="en-US" sz="1100" dirty="0"/>
           </a:p>
@@ -1885,7 +3765,7 @@
                   <a:srgbClr val="2F3A44"/>
                 </a:solidFill>
               </a:rPr>
-              <a:t>Completen con una formulación estricta: usuario afectado, tarea crítica, fricción actual, costo de no resolverlo y evidencia que respalda el problema.</a:t>
+              <a:t>El analista de costos y gastos necesita consolidar los gastos de producción y proponer el precio de venta de cada material editorial; hoy lo hace a mano en Excel, con demoras, riesgo de omisiones y sin trazabilidad.</a:t>
             </a:r>
             <a:endParaRPr lang="en-US" sz="1700" dirty="0"/>
           </a:p>
@@ -2211,7 +4091,7 @@
                   <a:srgbClr val="5F6B76"/>
                 </a:solidFill>
               </a:rPr>
-              <a:t>Eviten comenzar con “hicimos un chatbot”. El problema debe existir aunque la IA no exista.</a:t>
+              <a:t>El problema existe aunque la IA no exista: es un proceso contable manual, lento y con riesgo de error en cada cierre de costos.</a:t>
             </a:r>
             <a:endParaRPr lang="en-US" sz="950" dirty="0"/>
           </a:p>
@@ -2333,7 +4213,7 @@
                   <a:srgbClr val="5F6B76"/>
                 </a:solidFill>
               </a:rPr>
-              <a:t>Muestren por qué vale la pena resolverlo ahora.</a:t>
+              <a:t>El cierre de costos se repite en cada proyecto editorial: el mismo proceso manual, el mismo riesgo.</a:t>
             </a:r>
             <a:endParaRPr lang="en-US" sz="1100" dirty="0"/>
           </a:p>
@@ -2434,7 +4314,7 @@
                   <a:srgbClr val="2F3A44"/>
                 </a:solidFill>
               </a:rPr>
-              <a:t>Incluyan una evidencia mínima. Puede ser una medición del proceso, un ejemplo de usuario, una tasa de error, una demora promedio o un caso de decisión donde hoy falta información.</a:t>
+              <a:t>Evidencia del PoC: dataset de prueba con 4 proyectos editoriales y 20 gastos en MXN (9 tipos de gasto, 7 proveedores) que replica la fuente real; el sistema ya detecta registros inconsistentes en lugar de ocultarlos.</a:t>
             </a:r>
             <a:endParaRPr lang="en-US" sz="1700" dirty="0"/>
           </a:p>
@@ -2762,7 +4642,7 @@
         </p:nvSpPr>
         <p:spPr>
           <a:xfrm>
-            <a:off x="8366760" y="3127248"/>
+            <a:off x="8366760" y="3114548"/>
             <a:ext cx="2788920" cy="658368"/>
           </a:xfrm>
           <a:prstGeom prst="rect">
@@ -2773,20 +4653,28 @@
         </p:spPr>
         <p:txBody>
           <a:bodyPr wrap="square" lIns="0" tIns="0" rIns="0" bIns="0" rtlCol="0" anchor="ctr">
-            <a:normAutofit lnSpcReduction="10000"/>
+            <a:normAutofit fontScale="85000" lnSpcReduction="20000"/>
           </a:bodyPr>
           <a:lstStyle/>
           <a:p>
             <a:pPr marL="0" indent="0">
               <a:buNone/>
             </a:pPr>
+            <a:r>
+              <a:rPr lang="en-US" sz="1500" dirty="0" err="1">
+                <a:solidFill>
+                  <a:srgbClr val="2F3A44"/>
+                </a:solidFill>
+              </a:rPr>
+              <a:t>Consolidar</a:t>
+            </a:r>
             <a:r>
               <a:rPr lang="en-US" sz="1500" dirty="0">
                 <a:solidFill>
                   <a:srgbClr val="2F3A44"/>
                 </a:solidFill>
               </a:rPr>
-              <a:t>Consolidar gastos y proponer costo y precio en menos de 10 minutos</a:t>
+              <a:t> gastos y proponer costo y precio en menos de 10 minutos</a:t>
             </a:r>
             <a:endParaRPr lang="en-US" sz="1500" dirty="0"/>
           </a:p>
@@ -2872,7 +4760,7 @@
                   <a:srgbClr val="007D7A"/>
                 </a:solidFill>
               </a:rPr>
-              <a:t>Frase de cierre: “Por eso este proyecto no busca usar IA en abstracto; busca reducir el cálculo manual y los errores de costeo que hoy sufre el analista de costos y gastos”.</a:t>
+              <a:t>“Por eso este proyecto no busca usar IA en abstracto; busca reducir el cálculo manual y los errores de costeo que hoy sufre el analista de costos y gastos”.</a:t>
             </a:r>
             <a:endParaRPr lang="en-US" sz="1300" dirty="0"/>
           </a:p>
@@ -2994,7 +4882,7 @@
                   <a:srgbClr val="5F6B76"/>
                 </a:solidFill>
               </a:rPr>
-              <a:t>Presenten el sistema como una respuesta directa a la necesidad.</a:t>
+              <a:t>El sistema responde directamente a la necesidad: consolidar gastos y proponer precio con evidencia.</a:t>
             </a:r>
             <a:endParaRPr lang="en-US" sz="1100" dirty="0"/>
           </a:p>
@@ -3237,7 +5125,7 @@
                   <a:srgbClr val="102A43"/>
                 </a:solidFill>
               </a:rPr>
-              <a:t>Decisiones que deben quedar explícitas</a:t>
+              <a:t>Decisiones de diseño del PoC</a:t>
             </a:r>
             <a:endParaRPr lang="en-US" sz="1800" dirty="0"/>
           </a:p>
@@ -3369,7 +5257,7 @@
                   <a:srgbClr val="5F6B76"/>
                 </a:solidFill>
               </a:rPr>
-              <a:t>La audiencia debe entender qué hace el sistema y qué no hace, sin entrar todavía en todos los detalles del código.</a:t>
+              <a:t>Qué no hace: no ejecuta SQL libre, no modifica datos y no fija el precio final; la decisión queda en el analista.</a:t>
             </a:r>
             <a:endParaRPr lang="en-US" sz="950" dirty="0"/>
           </a:p>
@@ -3491,7 +5379,7 @@
                   <a:srgbClr val="5F6B76"/>
                 </a:solidFill>
               </a:rPr>
-              <a:t>La arquitectura convierte las decisiones del caso de uso en un producto ejecutable.</a:t>
+              <a:t>Flujo completo: pregunta en lenguaje natural → agente → tool MCP → SQLite → respuesta con evidencia.</a:t>
             </a:r>
             <a:endParaRPr lang="en-US" sz="1100" dirty="0"/>
           </a:p>
@@ -3975,7 +5863,7 @@
                   <a:srgbClr val="5F6B76"/>
                 </a:solidFill>
               </a:rPr>
-              <a:t>No basta con mostrar logos. Expliquen flujo: entrada del usuario → agente → tools → datos → respuesta con evidencia.</a:t>
+              <a:t>Cada corrida deja rastro: la propuesta se guarda en logs_inferencia (id, timestamp, score, latencia) y la traza completa de la ejecución queda en LangSmith.</a:t>
             </a:r>
             <a:endParaRPr lang="en-US" sz="950" dirty="0"/>
           </a:p>
@@ -4097,7 +5985,7 @@
                   <a:srgbClr val="5F6B76"/>
                 </a:solidFill>
               </a:rPr>
-              <a:t>No presenten solo beneficios. Expliquen qué mejora y a qué costo.</a:t>
+              <a:t>Qué mejora y a qué costo, dentro del alcance del PoC.</a:t>
             </a:r>
             <a:endParaRPr lang="en-US" sz="1100" dirty="0"/>
           </a:p>
@@ -4270,7 +6158,7 @@
                   <a:srgbClr val="2F3A44"/>
                 </a:solidFill>
               </a:rPr>
-              <a:t>El beneficio debe compararse contra el costo de implementación, mantenimiento, datos, uso del modelo y adopción del usuario. Una solución técnicamente sofisticada no es buena si el costo supera el valor demostrado.</a:t>
+              <a:t>Observado en el PoC: la propuesta de costo y precio se genera en segundos y queda registrada en logs de inferencia. Hipótesis por validar: reducción del ciclo frente a la línea base manual y tasa de aceptación del precio sugerido por el analista.</a:t>
             </a:r>
             <a:endParaRPr lang="en-US" sz="1700" dirty="0"/>
           </a:p>
@@ -4632,7 +6520,7 @@
                   <a:srgbClr val="5F6B76"/>
                 </a:solidFill>
               </a:rPr>
-              <a:t>Incluyan una métrica aunque sea preliminar: antes/después, tiempo, precisión, cobertura, satisfacción o reducción de pasos.</a:t>
+              <a:t>Métrica preliminar: el ciclo pasa de horas de consolidación manual a una consulta en segundos; cada cálculo registra su latencia y score en logs_inferencia.</a:t>
             </a:r>
             <a:endParaRPr lang="en-US" sz="950" dirty="0"/>
           </a:p>
@@ -4754,7 +6642,7 @@
                   <a:srgbClr val="5F6B76"/>
                 </a:solidFill>
               </a:rPr>
-              <a:t>Expliquen por qué esta solución puede competir con alternativas.</a:t>
+              <a:t>Por qué este enfoque es defendible frente a la alternativa manual.</a:t>
             </a:r>
             <a:endParaRPr lang="en-US" sz="1100" dirty="0"/>
           </a:p>
@@ -4927,7 +6815,7 @@
                   <a:srgbClr val="2F3A44"/>
                 </a:solidFill>
               </a:rPr>
-              <a:t>Competence no significa “somos los mejores”. Significa que el equipo entiende el dominio, las alternativas y las restricciones, y puede justificar por qué su enfoque es defendible.</a:t>
+              <a:t>El equipo domina el caso y sabe ejecutar: fichas de caso de uso, arquitectura y ETL completadas; PoC reproducible con README, servidor MCP con 13 tools de negocio, pruebas de caso feliz, límite y fuera de alcance, y trazas en LangSmith.</a:t>
             </a:r>
             <a:endParaRPr lang="en-US" sz="1700" dirty="0"/>
           </a:p>
@@ -5215,7 +7103,7 @@
                   <a:srgbClr val="007D7A"/>
                 </a:solidFill>
               </a:rPr>
-              <a:t>La credibilidad aumenta cuando reconocen límites y muestran cómo los controlan.</a:t>
+              <a:t>Los límites están controlados: la política de incertidumbre reporta los campos dudosos y toda propuesta queda auditada en los logs de inferencia.</a:t>
             </a:r>
             <a:endParaRPr lang="en-US" sz="1300" dirty="0"/>
           </a:p>
@@ -5418,7 +7306,7 @@
                   <a:srgbClr val="FFFFFF"/>
                 </a:solidFill>
               </a:rPr>
-              <a:t>[1] Usa la fuente correcta</a:t>
+              <a:t>[1] Usa la tool MCP correcta según la pregunta</a:t>
             </a:r>
             <a:endParaRPr lang="en-US" sz="1800" dirty="0"/>
           </a:p>
@@ -5432,7 +7320,7 @@
                   <a:srgbClr val="FFFFFF"/>
                 </a:solidFill>
               </a:rPr>
-              <a:t>[2] Responde con evidencia</a:t>
+              <a:t>[2] Responde con datos reales de SQLite</a:t>
             </a:r>
             <a:endParaRPr lang="en-US" sz="1800" dirty="0"/>
           </a:p>
@@ -5446,7 +7334,7 @@
                   <a:srgbClr val="FFFFFF"/>
                 </a:solidFill>
               </a:rPr>
-              <a:t>[3] Reconoce límites sin inventar</a:t>
+              <a:t>[3] Reconoce límites sin inventar (proyecto inexistente o inconsistente)</a:t>
             </a:r>
             <a:endParaRPr lang="en-US" sz="1800" dirty="0"/>
           </a:p>
@@ -5460,7 +7348,7 @@
                   <a:srgbClr val="FFFFFF"/>
                 </a:solidFill>
               </a:rPr>
-              <a:t>[4] El usuario puede operar el sistema</a:t>
+              <a:t>[4] El analista lo opera en lenguaje natural</a:t>
             </a:r>
             <a:endParaRPr lang="en-US" sz="1800" dirty="0"/>
           </a:p>
@@ -5496,7 +7384,7 @@
                   <a:srgbClr val="14B8D4"/>
                 </a:solidFill>
               </a:rPr>
-              <a:t>Pausar presentación y abrir sistema</a:t>
+              <a:t>Demo en vivo en el notebook</a:t>
             </a:r>
             <a:endParaRPr lang="en-US" sz="1600" dirty="0"/>
           </a:p>

</xml_diff>